<commit_message>
docs: support de soutenance Workshop2026-M1-G1-Pres.pptx (9 diapos) + diapo securite alignee
Deck cale sur docs/SCRIPT_ORAL.md : titre, menace, teaser, boitier, demo live,
IA, architecture, securite, conclusion. Notes d'orateur par diapo. Mise en page
verifiee diapo par diapo (rendu de controle avec polices plus larges), TLS
formule en 1.2 et plus (BearSSL sur ESP8266).

Co-Authored-By: Claude Fable 5.1 <noreply@anthropic.com>
</commit_message>
<xml_diff>
--- a/livrables/Workshop2026-M1-G1-Diapo-Securite.pptx
+++ b/livrables/Workshop2026-M1-G1-Diapo-Securite.pptx
@@ -503,7 +503,7 @@
             <a:r>
               <a:rPr lang="en-US" dirty="0"/>
               <a:t>Message : la liaison est sûre par couches, pas par un seul verrou.
-1) Chiffrement : le boîtier parle au serveur en MQTT sur TLS 1.3. Même sur le hotspot partagé avec les autres groupes, nos mesures et nos commandes sont illisibles au sniffing. L'ESP épingle l'empreinte du certificat, donc impossible de se faire passer pour le serveur.
+1) Chiffrement : le boîtier parle au serveur en MQTT sur TLS (1.2 sur l'ESP8266, 1.3 côté serveur). Même sur le hotspot partagé avec les autres groupes, nos mesures et nos commandes sont illisibles au sniffing. L'ESP épingle l'empreinte du certificat, donc impossible de se faire passer pour le serveur.
 2) Authentification : le broker refuse l'anonyme ; toute écriture sur l'API demande une clé. Démo : un pub ou un POST sans identifiants est rejeté.
 3) Cloisonnement : la base n'a aucun port ouvert, et la clé API reste côté serveur, jamais dans le navigateur.
 4) Détection : pendant le pentest, watch-attacks.sh affiche en direct les connexions d'IP inconnues et les échecs d'auth.
@@ -999,7 +999,7 @@
                 <a:ea typeface="Calibri" pitchFamily="34" charset="-122"/>
                 <a:cs typeface="Calibri" pitchFamily="34" charset="-120"/>
               </a:rPr>
-              <a:t>MQTTS · TLS 1.3</a:t>
+              <a:t>MQTT sur TLS</a:t>
             </a:r>
             <a:endParaRPr lang="en-US" sz="1300" dirty="0"/>
           </a:p>
@@ -1593,7 +1593,7 @@
                 <a:ea typeface="Calibri" pitchFamily="34" charset="-122"/>
                 <a:cs typeface="Calibri" pitchFamily="34" charset="-120"/>
               </a:rPr>
-              <a:t>TLS 1.3</a:t>
+              <a:t>TLS</a:t>
             </a:r>
             <a:endParaRPr lang="en-US" sz="1000" dirty="0"/>
           </a:p>
@@ -1773,7 +1773,7 @@
                 <a:ea typeface="Calibri" pitchFamily="34" charset="-122"/>
                 <a:cs typeface="Calibri" pitchFamily="34" charset="-120"/>
               </a:rPr>
-              <a:t>TLS 1.3 de bout en bout. Trafic Wi-Fi illisible, même sur un réseau partagé.</a:t>
+              <a:t>TLS 1.2 et plus de bout en bout. Trafic Wi-Fi illisible, même sur un réseau partagé.</a:t>
             </a:r>
             <a:endParaRPr lang="en-US" sz="1200" dirty="0"/>
           </a:p>
@@ -2196,7 +2196,7 @@
               <a:buNone/>
             </a:pPr>
             <a:r>
-              <a:rPr lang="en-US" sz="1250" dirty="0">
+              <a:rPr lang="en-US" sz="1200" dirty="0">
                 <a:solidFill>
                   <a:srgbClr val="AFC9E6"/>
                 </a:solidFill>
@@ -2210,7 +2210,7 @@
               <a:buNone/>
             </a:pPr>
             <a:r>
-              <a:rPr lang="en-US" sz="1250" b="1" dirty="0">
+              <a:rPr lang="en-US" sz="1200" b="1" dirty="0">
                 <a:solidFill>
                   <a:srgbClr val="F4B740"/>
                 </a:solidFill>
@@ -2224,7 +2224,7 @@
               <a:buNone/>
             </a:pPr>
             <a:r>
-              <a:rPr lang="en-US" sz="1250" dirty="0">
+              <a:rPr lang="en-US" sz="1200" dirty="0">
                 <a:solidFill>
                   <a:srgbClr val="AFC9E6"/>
                 </a:solidFill>
@@ -2232,13 +2232,13 @@
                 <a:ea typeface="Courier New" pitchFamily="34" charset="-122"/>
                 <a:cs typeface="Courier New" pitchFamily="34" charset="-120"/>
               </a:rPr>
-              <a:t>        POST /commands sans clé</a:t>
+              <a:t>      POST /commands sans clé</a:t>
             </a:r>
             <a:pPr algn="l" indent="0" marL="0">
               <a:buNone/>
             </a:pPr>
             <a:r>
-              <a:rPr lang="en-US" sz="1250" b="1" dirty="0">
+              <a:rPr lang="en-US" sz="1200" b="1" dirty="0">
                 <a:solidFill>
                   <a:srgbClr val="F4B740"/>
                 </a:solidFill>
@@ -2252,7 +2252,7 @@
               <a:buNone/>
             </a:pPr>
             <a:r>
-              <a:rPr lang="en-US" sz="1250" dirty="0">
+              <a:rPr lang="en-US" sz="1200" dirty="0">
                 <a:solidFill>
                   <a:srgbClr val="AFC9E6"/>
                 </a:solidFill>
@@ -2260,13 +2260,13 @@
                 <a:ea typeface="Courier New" pitchFamily="34" charset="-122"/>
                 <a:cs typeface="Courier New" pitchFamily="34" charset="-120"/>
               </a:rPr>
-              <a:t>        GET / sans mot de passe</a:t>
+              <a:t>      GET / sans mot de passe</a:t>
             </a:r>
             <a:pPr algn="l" indent="0" marL="0">
               <a:buNone/>
             </a:pPr>
             <a:r>
-              <a:rPr lang="en-US" sz="1250" b="1" dirty="0">
+              <a:rPr lang="en-US" sz="1200" b="1" dirty="0">
                 <a:solidFill>
                   <a:srgbClr val="F4B740"/>
                 </a:solidFill>
@@ -2276,7 +2276,7 @@
               </a:rPr>
               <a:t>  →  401</a:t>
             </a:r>
-            <a:endParaRPr lang="en-US" sz="1250" dirty="0"/>
+            <a:endParaRPr lang="en-US" sz="1200" dirty="0"/>
           </a:p>
         </p:txBody>
       </p:sp>

</xml_diff>